<commit_message>
Add Thai speaking script and rework slide 10 as two patient entry paths
Ball-SD asked for a full Thai narration script per slide, and for the
referral-slip QR slide to be reframed around how a patient/visitor actually
activates CarePath: LINE LIFF (built) and scanning a QR on the hospital's
existing ใบนำทาง (proposed), since every hospital already has that document.

Co-Authored-By: Claude Sonnet 5 <noreply@anthropic.com>
</commit_message>
<xml_diff>
--- a/docs/deliverables/presentation-outline-hospital-review.pptx
+++ b/docs/deliverables/presentation-outline-hospital-review.pptx
@@ -515,7 +515,8 @@
           <a:p>
             <a:r>
               <a:rPr lang="en-US" dirty="0"/>
-              <a:t>0:10 — เปิดตัว CarePath สั้น ๆ แนะนำทีม แล้วเข้าเรื่องปัญหาทันที</a:t>
+              <a:t>0:10
+สวัสดีครับ ทีม OST-1 วันนี้ขอนำเสนอ CarePath ระบบนำทางผู้ป่วยภายในโรงพยาบาล ที่ออกแบบมาให้ทำงานร่วมกับระบบ HIS เดิมของโรงพยาบาลได้โดยตรง โดยไม่ต้องแทนที่ระบบเดิม</a:t>
             </a:r>
             <a:endParaRPr lang="en-US" dirty="0"/>
           </a:p>
@@ -603,7 +604,8 @@
           <a:p>
             <a:r>
               <a:rPr lang="en-US" dirty="0"/>
-              <a:t>~20s — ย้ำชัดว่านี่คือ "แนวคิด" ยังไม่ได้พัฒนา เป็นการต่อยอด QR pattern ที่มีอยู่แล้ว ถ้าถูกถามว่าทำแล้วหรือยังให้ตอบตรง ๆ ว่ายัง.</a:t>
+              <a:t>~20s
+มีสองแนวทางที่ผู้มารับบริการจะเปิดใช้งาน CarePath ได้ แนวทางแรกคือผ่าน LINE LIFF ซึ่งใช้งานได้แล้ววันนี้ แนวทางที่สองที่อยากนำเสนอเพิ่มเติม แต่ขอย้ำว่ายังไม่ได้พัฒนาจริง คือการเพิ่ม QR code ลงบนใบนำทางที่โรงพยาบาลใช้อยู่แล้ว เมื่อผู้ป่วยสแกน ก็จะเข้าสู่หน้า journey ของตัวเองใน CarePath ได้ทันที เหตุผลที่เลือกใบนำทางเป็นจุดเริ่มต้น เพราะทุกโรงพยาบาลมีเอกสารนี้อยู่แล้ว ไม่ต้องออกแบบเอกสารใหม่ ทั้งสองแนวทางพาไปสู่หน้า journey เดียวกัน</a:t>
             </a:r>
             <a:endParaRPr lang="en-US" dirty="0"/>
           </a:p>
@@ -691,7 +693,10 @@
           <a:p>
             <a:r>
               <a:rPr lang="en-US" dirty="0"/>
-              <a:t>~20s — สองคอลัมน์เทียบกัน เห็น/ไม่เห็น แล้วปิดด้วยเหตุผลด้านล่าง: ไม่ต้อง login, หมดอายุเอง, เพิกถอนได้, token ไม่หลุด log. ฟีเจอร์นี้ทำแล้วจริง (ADR-0011).</a:t>
+              <a:t>~20s
+ฟีเจอร์ที่ทำเสร็จแล้วจริง คือการแชร์ความคืบหน้าให้ญาติ ผู้ป่วยสร้างลิงก์แชร์จากหน้าจอของตัวเองได้
+ญาติที่เปิดลิงก์นี้จะเห็นได้แค่ขั้นตอนปัจจุบันเป็นข้อความอ่านง่าย สถานะหยาบ ๆ ว่ารอ กำลังทำ หรือเสร็จแล้ว ชื่อจุดบริการและชั้น รวมถึงเวลาที่อัปเดตล่าสุด แต่จะไม่เห็นชื่อผู้ป่วย เลข HN หรือ VN รหัสขั้นตอนภายใน หรือรายการคำสั่งตรวจใด ๆ เลย
+เหตุผลคือญาติไม่ใช่บุคคลที่ระบบรู้จัก จึงไม่ต้องล็อกอิน ลิงก์หมดอายุอัตโนมัติภายในสี่ชั่วโมง ผู้ป่วยเพิกถอนได้ทุกเมื่อ และตัว token จะไม่ปรากฏใน URL ที่ server มองเห็น จึงไม่มีทางหลุดเข้าไปอยู่ใน log</a:t>
             </a:r>
             <a:endParaRPr lang="en-US" dirty="0"/>
           </a:p>
@@ -779,7 +784,11 @@
           <a:p>
             <a:r>
               <a:rPr lang="en-US" dirty="0"/>
-              <a:t>2:30 — สลับไปหน้าจอสาธิตจริง (Mock HIS console + patient app + แผนที่) เดินตาม 6 ขั้นบนสไลด์นี้เป็น cue card ไม่ต้องพูดซ้ำสไลด์ พูดคุยไปพร้อมคลิกจริง.</a:t>
+              <a:t>นำเข้าเดโม ก่อนสลับจอจริง (2:30)
+ต่อไปขอสาธิตของจริงครับ โดยจะขับเคลื่อนด้วย Mock HIS ทั้งหมด
+เริ่มจากเปิด VN ใหม่แบบสด ๆ เป็นนัดหมายที่มีคำสั่งตรวจล่วงหน้า จากนั้นให้ผลตรวจออก ทำให้ขั้นตอนพบแพทย์พร้อมใช้งาน ระหว่างพบแพทย์จะสั่งตรวจเพิ่ม แล้วให้ผู้ป่วยกลับมาหาหมอคนเดิม ปิดรอบแล้วไปที่การเงินและห้องยา และตลอดทั้งเส้นทางนี้ แผนที่และเส้นทางเดินจะอัปเดตให้เองทุกขั้นตอน
+ทั้งหมดนี้คือเส้นทางเดียวกับที่ถูกทดสอบอัตโนมัติทุกวันใน CI ของเรา สิ่งที่ท่านกำลังจะเห็นคือสิ่งที่ผ่านการทดสอบจริงทุกวัน
+[สลับไปหน้าจอจริง — Mock HIS console → Patient app → แผนที่/เส้นทาง ตามลำดับ 6 ขั้นในสไลด์ ไม่ต้องพูดซ้ำสไลด์ พูดคุยไปพร้อมคลิกจริง ใช้เวลา 2:30]</a:t>
             </a:r>
             <a:endParaRPr lang="en-US" dirty="0"/>
           </a:p>
@@ -867,7 +876,11 @@
           <a:p>
             <a:r>
               <a:rPr lang="en-US" dirty="0"/>
-              <a:t>0:45 — ภาพรวม stack ซ้าย, core runtime chain กับ modular monolith ขวา ไม่ต้องลงลึกทุกโมดูล ชี้ที่ diagram แล้วอธิบายภาพรวม.</a:t>
+              <a:t>0:45
+สุดท้ายขอสรุปภาพรวมด้านเทคนิค
+ฝั่ง frontend ใช้ React เวอร์ชัน 19 TypeScript และ Vite ร่วมกับ Tailwind และ TanStack Query กับ Router ฝั่ง backend ใช้ภาษา Go กับเฟรมเวิร์ก Fiber เวอร์ชัน 3 ออกแบบ API แบบ contract-first ด้วย OpenAPI ฐานข้อมูลใช้ PostgreSQL การ deploy วันนี้ใช้ Docker Compose แต่โครงสร้างพร้อมขยายไปสู่ Kubernetes ได้ในอนาคต
+ในเชิงสถาปัตยกรรม เราออกแบบเป็น modular monolith ไม่ใช่ microservices เพื่อความเร็วในการประสานงานของทีมตอนนี้ แต่ละโมดูลมีขอบเขตชัดเจนแบบ hexagonal จึงแยกออกไปเป็นบริการเดี่ยวในอนาคตได้โดยไม่ต้องเขียนใหม่ทั้งหมด
+และแกนกลางของระบบคือสายการคำนวณจากข้อเท็จจริงของ visit ไปสู่แผนการดูแล จุดบริการ สถานที่ จุดในกราฟนำทาง จนถึงเส้นทางสุดท้าย</a:t>
             </a:r>
             <a:endParaRPr lang="en-US" dirty="0"/>
           </a:p>
@@ -955,7 +968,8 @@
           <a:p>
             <a:r>
               <a:rPr lang="en-US" dirty="0"/>
-              <a:t>0:15 — ปิดท้ายสั้น ๆ ขอบคุณ เปิดรับคำถาม.</a:t>
+              <a:t>0:15
+ขอบคุณครับ นี่คือภาพรวมของ CarePath ทั้งในมุมผู้ป่วย เจ้าหน้าที่ ผู้บริหาร และด้านเทคนิค ทีม OST-1 พร้อมตอบคำถามครับ</a:t>
             </a:r>
             <a:endParaRPr lang="en-US" dirty="0"/>
           </a:p>
@@ -1043,7 +1057,11 @@
           <a:p>
             <a:r>
               <a:rPr lang="en-US" dirty="0"/>
-              <a:t>0:30 — ผู้ป่วยหลงทาง / ไม่รู้ขั้นตอนถัดไป / เจ้าหน้าที่เสียเวลาตอบคำถามเส้นทาง พูดสั้น เน้น 3 ประเด็นบนสไลด์ ที่เหลือพูดเสริมด้วยปาก.</a:t>
+              <a:t>0:30
+เราเริ่มจากปัญหาที่พบจริงในโรงพยาบาลสามเรื่องหลัก
+เรื่องแรก ผู้ป่วยหลงทางเมื่อต้องเดินข้ามอาคารหรือข้ามชั้น โดยเฉพาะผู้สูงอายุ ผู้ใช้รถเข็น และผู้ที่มาโรงพยาบาลเป็นครั้งแรก
+เรื่องที่สอง ผู้ป่วยไม่รู้ว่าขั้นตอนถัดไปคืออะไร เหลืออีกกี่ขั้นตอน ต้องรออีกนานแค่ไหน และขั้นตอนถัดไปอยู่ที่จุดไหนของโรงพยาบาล
+เรื่องที่สาม เจ้าหน้าที่ต้องเสียเวลาตอบคำถามเรื่องเส้นทางซ้ำ ๆ ทั้งวัน แทนที่จะได้ใช้เวลาไปกับการดูแลผู้ป่วยจริง ๆ</a:t>
             </a:r>
             <a:endParaRPr lang="en-US" dirty="0"/>
           </a:p>
@@ -1131,7 +1149,8 @@
           <a:p>
             <a:r>
               <a:rPr lang="en-US" dirty="0"/>
-              <a:t>~15s — Care Graph ตอบว่า "ต่อไปทำอะไร" Navigation Graph ตอบว่า "ไปยังไง" เชื่อมกันผ่าน ServicePoint→Place เท่านั้น (ADR-0002).</a:t>
+              <a:t>~15s
+CarePath คือผู้ช่วยนำทางส่วนตัวของผู้ป่วย ตลอดการมาโรงพยาบาลในแต่ละครั้ง เราตั้งใจแยกสองเรื่องนี้ออกจากกันอย่างชัดเจน คือ Care Graph ที่ตอบว่าขั้นตอนถัดไปคืออะไร กับ Navigation Graph ที่ตอบว่าจะไปถึงจุดนั้นได้อย่างไร ทั้งสองส่วนเชื่อมกันผ่านแนวคิด ServicePoint ไปยัง Place เท่านั้น ทำให้การเปลี่ยนขั้นตอนดูแลรักษา กับการเปลี่ยนผังอาคาร ไม่ไปกระทบโค้ดส่วนเดียวกัน</a:t>
             </a:r>
             <a:endParaRPr lang="en-US" dirty="0"/>
           </a:p>
@@ -1219,7 +1238,9 @@
           <a:p>
             <a:r>
               <a:rPr lang="en-US" dirty="0"/>
-              <a:t>~20s — ย้ำให้ชัดว่า HIS เป็นเจ้าของ visit/order/encounter เสมอ CarePath ได้แค่สร้างแผนดูแลที่ derive มาจากข้อมูลนั้น ไม่ทับสิทธิ์ HIS.</a:t>
+              <a:t>~20s
+ก่อนอื่นต้องย้ำให้ชัดเจนว่า HIS ของโรงพยาบาลยังคงเป็นเจ้าของข้อมูลหลักเหมือนเดิมทุกประการ ทั้งข้อมูล visit การมอบหมายคลินิก คำสั่งตรวจ ผลตรวจ และการปิดการตรวจ
+CarePath ไม่เข้าไปเขียนทับข้อมูลเหล่านี้เลย สิ่งที่ CarePath ทำคือ "อ่าน" ข้อเท็จจริงเหล่านั้น แล้วคำนวณออกมาเป็นแผนการดูแลผู้ป่วยของตัวเอง ส่วนการจับคู่จุดบริการกับตำแหน่งจริงในอาคาร และการนำทาง ก็เป็นหน้าที่ของ CarePath เองเช่นกัน</a:t>
             </a:r>
             <a:endParaRPr lang="en-US" dirty="0"/>
           </a:p>
@@ -1307,7 +1328,10 @@
           <a:p>
             <a:r>
               <a:rPr lang="en-US" dirty="0"/>
-              <a:t>~20s — CarePath ไม่แตะ DB ของ HIS เลย คุยผ่าน adapter ด้วย "ข้อเท็จจริง" 8 อย่างเท่านั้น สลับเป็น HIS จริงทีหลัง แก้แค่ adapter ตัวเดียว (ADR-0005, ADR-0008/0009).</a:t>
+              <a:t>~20s
+การเชื่อมต่อกับ HIS ออกแบบให้ปลอดภัยและยืดหยุ่น CarePath จะไม่มีการอ่านฐานข้อมูลของ HIS โดยตรงเด็ดขาด แต่เชื่อมผ่าน HIS Adapter ตัวกลางเท่านั้น
+วันนี้ Adapter ตัวนี้ต่อกับ Mock HIS สำหรับพัฒนาและสาธิต แต่โครงสร้างเดียวกันนี้รองรับการเปลี่ยนไปต่อกับ HIS จริงของโรงพยาบาลได้ในอนาคต โดยไม่ต้องแก้โค้ดส่วน journey หรือ navigation เลย
+ตัว Adapter รับข้อเท็จจริงมาตรฐาน 8 อย่างจาก HIS ผ่าน REST API เช่น การเปิด visit การสั่งตรวจ ผลตรวจออก และการปิดการตรวจ ทุกอย่างเป็น idempotent คือส่งซ้ำได้โดยไม่เกิดผลข้างเคียง</a:t>
             </a:r>
             <a:endParaRPr lang="en-US" dirty="0"/>
           </a:p>
@@ -1395,7 +1419,9 @@
           <a:p>
             <a:r>
               <a:rPr lang="en-US" dirty="0"/>
-              <a:t>~15s — โชว์ว่า planner เป็น pure function ไม่มีผลข้างเคียง คำนวณใหม่ทุกครั้ง สะท้อน flow OPD จริงรวมถึงกรณีกลับไปหาหมอคนเดิม.</a:t>
+              <a:t>~15s
+จากนั้น CarePath นำข้อเท็จจริงเหล่านี้มาคำนวณเป็นแผนการเดินทางของผู้ป่วยด้วยฟังก์ชันที่เรียกว่า Plan ซึ่งเป็น pure function คำนวณใหม่ทุกครั้งที่มีข้อมูลใหม่เข้ามา ไม่มีผลข้างเคียงใด ๆ
+กฎที่ใช้คำนวณสะท้อนขั้นตอนจริงของแผนก OPD เช่น ลงทะเบียนก่อนเสมอ ถ้าเป็นนัดหมายที่มีคำสั่งตรวจล่วงหน้าก็จะตรวจ Lab หรือ X-ray ก่อนพบแพทย์ ถ้าหมอสั่งตรวจเพิ่มระหว่างพบผู้ป่วยก็จะกลับมาหาหมอคนเดิมหลังตรวจเสร็จ การเงินเกิดขึ้นครั้งเดียวเสมอไม่ว่าจะกี่คลินิก และห้องยาจะปรากฏเฉพาะเมื่อมีการสั่งยาเท่านั้น</a:t>
             </a:r>
             <a:endParaRPr lang="en-US" dirty="0"/>
           </a:p>
@@ -1483,7 +1509,11 @@
           <a:p>
             <a:r>
               <a:rPr lang="en-US" dirty="0"/>
-              <a:t>0:30 — เดินตามลำดับ 4 ขั้นนี้ อาจเปิดหน้าจอจริงประกอบสั้น ๆ เน้นว่าไม่มี GPS ในอาคารจึงต้องรู้ตำแหน่งจาก QR/Zigbee ก่อน.</a:t>
+              <a:t>0:30
+ต่อไปขอพาไปดูสิ่งที่ผู้ป่วยเห็นจริง ๆ ตั้งแต่ต้นจนจบ
+เริ่มจากผู้ป่วยเปิดแอปผ่าน LINE LIFF หรือค้นหาด้วยเลข VN จากนั้นจะเห็น timeline แสดงขั้นตอนที่เสร็จแล้ว ขั้นตอนปัจจุบัน และขั้นตอนถัดไป
+เมื่อกดปุ่มนำทาง ระบบจะพาไปยังจุดหมาย โดยต้องรู้ตำแหน่งปัจจุบันก่อนผ่าน QR หรือ Zigbee เพราะในอาคารไม่มีสัญญาณ GPS
+และที่สำคัญคือหน้าจอทั้งหมดนี้อัปเดตสดโดยอัตโนมัติทันทีที่มีข้อเท็จจริงใหม่จาก HIS ผู้ป่วยไม่ต้องกดรีเฟรชเอง</a:t>
             </a:r>
             <a:endParaRPr lang="en-US" dirty="0"/>
           </a:p>
@@ -1571,7 +1601,12 @@
           <a:p>
             <a:r>
               <a:rPr lang="en-US" dirty="0"/>
-              <a:t>~20s — พูดแบบ list ไม่ลงลึก: login RBAC, รายการผู้ป่วย, คอนโซลจุดบริการ, และ mock HIS console (เดโมเท่านั้น ไม่ใช่ของจริง).</a:t>
+              <a:t>~20s
+ฝั่งเจ้าหน้าที่ ขอพูดแบบภาพรวมสั้น ๆ มีสี่ส่วนหลักที่ทำเสร็จแล้ว
+หนึ่ง การล็อกอินตามสิทธิ์การใช้งาน ด้วยรหัสผ่านที่เข้ารหัสอย่างปลอดภัยและ JWT token
+สอง รายการผู้ป่วยที่เปิด visit อยู่ สำหรับเจ้าหน้าที่ลงทะเบียน
+สาม คอนโซลจุดบริการ สำหรับเริ่มและจบขั้นตอน รวมถึง override กรณีที่ต้องกลับไปหาหมอคนเดิมผิดไปจากที่ระบบคาดการณ์
+และสุดท้าย Mock HIS console ซึ่งใช้แทนระบบ HIS จริงในช่วงพัฒนาเท่านั้น ระบบที่ใช้งานจริงในโรงพยาบาลจะไม่มีหน้านี้</a:t>
             </a:r>
             <a:endParaRPr lang="en-US" dirty="0"/>
           </a:p>
@@ -1659,7 +1694,9 @@
           <a:p>
             <a:r>
               <a:rPr lang="en-US" dirty="0"/>
-              <a:t>~20s — บอกว่ามีอะไรบ้าง (3 การ์ดบน) แล้วเน้น "ทำไม" — ไม่ต้องเก็บข้อมูลเพิ่ม ใช้ของเดิมที่มีอยู่แล้ว เป็นเหตุผลที่ผู้บริหารควรสนใจ CarePath.</a:t>
+              <a:t>~20s
+อีกส่วนที่อยากให้ความสำคัญคือ Executive Dashboard สำหรับผู้บริหาร แสดงเวลารอเฉลี่ยของแต่ละจุดบริการ จุดที่เป็นคอขวดที่ผู้ป่วยรอนานผิดปกติ และเวลารวมที่ผู้ป่วยใช้ในโรงพยาบาลโดยเฉลี่ย
+ที่สำคัญคือข้อมูลเหล่านี้มาจากข้อมูลที่ระบบเก็บอยู่แล้วจากฟีเจอร์นำทางผู้ป่วย โรงพยาบาลไม่ต้องติดตั้งอะไรเพิ่มเลย นี่คือเหตุผลที่ผู้บริหารควรสนใจ CarePath ไม่ใช่แค่มุมประสบการณ์ผู้ป่วย แต่เป็นข้อมูลสำหรับตัดสินใจจัดสรรกำลังคนจริง ๆ</a:t>
             </a:r>
             <a:endParaRPr lang="en-US" dirty="0"/>
           </a:p>
@@ -2332,7 +2369,7 @@
                 <a:ea typeface="Calibri" pitchFamily="34" charset="-122"/>
                 <a:cs typeface="Calibri" pitchFamily="34" charset="-120"/>
               </a:rPr>
-              <a:t>แนวคิดเพิ่มเติม</a:t>
+              <a:t>จุดเริ่มต้นเข้าใช้งาน</a:t>
             </a:r>
             <a:endParaRPr lang="en-US" sz="1200" dirty="0"/>
           </a:p>
@@ -2371,7 +2408,7 @@
                 <a:ea typeface="Cambria" pitchFamily="34" charset="-122"/>
                 <a:cs typeface="Cambria" pitchFamily="34" charset="-120"/>
               </a:rPr>
-              <a:t>QR บนใบนำทาง — จุดเริ่มต้นเข้าสู่ CarePath</a:t>
+              <a:t>ผู้มารับบริการเปิดใช้งาน CarePath ได้อย่างไร</a:t>
             </a:r>
             <a:endParaRPr lang="en-US" sz="3000" dirty="0"/>
           </a:p>
@@ -2385,8 +2422,257 @@
         </p:nvSpPr>
         <p:spPr>
           <a:xfrm>
-            <a:off x="9722815" y="457200"/>
-            <a:ext cx="1920240" cy="384048"/>
+            <a:off x="548640" y="1965960"/>
+            <a:ext cx="5272888" cy="3063240"/>
+          </a:xfrm>
+          <a:prstGeom prst="roundRect">
+            <a:avLst>
+              <a:gd name="adj" fmla="val 3582"/>
+            </a:avLst>
+          </a:prstGeom>
+          <a:solidFill>
+            <a:srgbClr val="EAF6F4"/>
+          </a:solidFill>
+          <a:ln/>
+          <a:effectLst>
+            <a:outerShdw sx="100000" sy="100000" kx="0" ky="0" algn="bl" rotWithShape="0" blurRad="101600" dist="25400" dir="5400000">
+              <a:srgbClr val="1B3A38">
+                <a:alpha val="15000"/>
+              </a:srgbClr>
+            </a:outerShdw>
+          </a:effectLst>
+        </p:spPr>
+      </p:sp>
+      <p:sp>
+        <p:nvSpPr>
+          <p:cNvPr id="5" name="Shape 3"/>
+          <p:cNvSpPr/>
+          <p:nvPr/>
+        </p:nvSpPr>
+        <p:spPr>
+          <a:xfrm>
+            <a:off x="3855568" y="2194560"/>
+            <a:ext cx="1737360" cy="365760"/>
+          </a:xfrm>
+          <a:prstGeom prst="roundRect">
+            <a:avLst>
+              <a:gd name="adj" fmla="val 50000"/>
+            </a:avLst>
+          </a:prstGeom>
+          <a:solidFill>
+            <a:srgbClr val="E3F6EE"/>
+          </a:solidFill>
+          <a:ln w="12700">
+            <a:solidFill>
+              <a:srgbClr val="0E8A5F"/>
+            </a:solidFill>
+            <a:prstDash val="solid"/>
+          </a:ln>
+        </p:spPr>
+      </p:sp>
+      <p:sp>
+        <p:nvSpPr>
+          <p:cNvPr id="6" name="Text 4"/>
+          <p:cNvSpPr txBox="1"/>
+          <p:nvPr/>
+        </p:nvSpPr>
+        <p:spPr>
+          <a:xfrm>
+            <a:off x="3855568" y="2194560"/>
+            <a:ext cx="1737360" cy="365760"/>
+          </a:xfrm>
+          <a:prstGeom prst="rect">
+            <a:avLst/>
+          </a:prstGeom>
+          <a:noFill/>
+          <a:ln/>
+        </p:spPr>
+        <p:txBody>
+          <a:bodyPr wrap="square" lIns="0" tIns="0" rIns="0" bIns="0" rtlCol="0" anchor="ctr"/>
+          <a:lstStyle/>
+          <a:p>
+            <a:pPr algn="ctr" indent="0" marL="0">
+              <a:buNone/>
+            </a:pPr>
+            <a:r>
+              <a:rPr lang="en-US" sz="1050" b="1" dirty="0">
+                <a:solidFill>
+                  <a:srgbClr val="0E8A5F"/>
+                </a:solidFill>
+                <a:latin typeface="Calibri" pitchFamily="34" charset="0"/>
+                <a:ea typeface="Calibri" pitchFamily="34" charset="-122"/>
+                <a:cs typeface="Calibri" pitchFamily="34" charset="-120"/>
+              </a:rPr>
+              <a:t>ใช้งานได้แล้ว</a:t>
+            </a:r>
+            <a:endParaRPr lang="en-US" sz="1050" dirty="0"/>
+          </a:p>
+        </p:txBody>
+      </p:sp>
+      <p:sp>
+        <p:nvSpPr>
+          <p:cNvPr id="7" name="Shape 5"/>
+          <p:cNvSpPr/>
+          <p:nvPr/>
+        </p:nvSpPr>
+        <p:spPr>
+          <a:xfrm>
+            <a:off x="868680" y="2286000"/>
+            <a:ext cx="777240" cy="777240"/>
+          </a:xfrm>
+          <a:prstGeom prst="ellipse">
+            <a:avLst/>
+          </a:prstGeom>
+          <a:solidFill>
+            <a:srgbClr val="028090"/>
+          </a:solidFill>
+          <a:ln/>
+        </p:spPr>
+      </p:sp>
+      <p:pic>
+        <p:nvPicPr>
+          <p:cNvPr id="8" name="Image 0" descr="preencoded.png">    </p:cNvPr>
+          <p:cNvPicPr>
+            <a:picLocks noChangeAspect="1"/>
+          </p:cNvPicPr>
+          <p:nvPr/>
+        </p:nvPicPr>
+        <p:blipFill>
+          <a:blip r:embed="rId1"/>
+          <a:stretch>
+            <a:fillRect/>
+          </a:stretch>
+        </p:blipFill>
+        <p:spPr>
+          <a:xfrm>
+            <a:off x="1069848" y="2487168"/>
+            <a:ext cx="374904" cy="374904"/>
+          </a:xfrm>
+          <a:prstGeom prst="rect">
+            <a:avLst/>
+          </a:prstGeom>
+        </p:spPr>
+      </p:pic>
+      <p:sp>
+        <p:nvSpPr>
+          <p:cNvPr id="9" name="Text 6"/>
+          <p:cNvSpPr txBox="1"/>
+          <p:nvPr/>
+        </p:nvSpPr>
+        <p:spPr>
+          <a:xfrm>
+            <a:off x="868680" y="3246120"/>
+            <a:ext cx="4632808" cy="411480"/>
+          </a:xfrm>
+          <a:prstGeom prst="rect">
+            <a:avLst/>
+          </a:prstGeom>
+          <a:noFill/>
+          <a:ln/>
+        </p:spPr>
+        <p:txBody>
+          <a:bodyPr wrap="square" lIns="0" tIns="0" rIns="0" bIns="0" rtlCol="0" anchor="ctr"/>
+          <a:lstStyle/>
+          <a:p>
+            <a:pPr indent="0" marL="0">
+              <a:buNone/>
+            </a:pPr>
+            <a:r>
+              <a:rPr lang="en-US" sz="1700" b="1" dirty="0">
+                <a:solidFill>
+                  <a:srgbClr val="17262A"/>
+                </a:solidFill>
+                <a:latin typeface="Cambria" pitchFamily="34" charset="0"/>
+                <a:ea typeface="Cambria" pitchFamily="34" charset="-122"/>
+                <a:cs typeface="Cambria" pitchFamily="34" charset="-120"/>
+              </a:rPr>
+              <a:t>แนวทางที่ 1 — LINE LIFF</a:t>
+            </a:r>
+            <a:endParaRPr lang="en-US" sz="1700" dirty="0"/>
+          </a:p>
+        </p:txBody>
+      </p:sp>
+      <p:sp>
+        <p:nvSpPr>
+          <p:cNvPr id="10" name="Text 7"/>
+          <p:cNvSpPr txBox="1"/>
+          <p:nvPr/>
+        </p:nvSpPr>
+        <p:spPr>
+          <a:xfrm>
+            <a:off x="868680" y="3749040"/>
+            <a:ext cx="4632808" cy="1005840"/>
+          </a:xfrm>
+          <a:prstGeom prst="rect">
+            <a:avLst/>
+          </a:prstGeom>
+          <a:noFill/>
+          <a:ln/>
+        </p:spPr>
+        <p:txBody>
+          <a:bodyPr wrap="square" lIns="0" tIns="0" rIns="0" bIns="0" rtlCol="0" anchor="ctr"/>
+          <a:lstStyle/>
+          <a:p>
+            <a:pPr indent="0" marL="0">
+              <a:lnSpc>
+                <a:spcPct val="120000"/>
+              </a:lnSpc>
+              <a:buNone/>
+            </a:pPr>
+            <a:r>
+              <a:rPr lang="en-US" sz="1300" dirty="0">
+                <a:solidFill>
+                  <a:srgbClr val="5A6E6C"/>
+                </a:solidFill>
+                <a:latin typeface="Calibri" pitchFamily="34" charset="0"/>
+                <a:ea typeface="Calibri" pitchFamily="34" charset="-122"/>
+                <a:cs typeface="Calibri" pitchFamily="34" charset="-120"/>
+              </a:rPr>
+              <a:t>เปิดผ่าน LINE OA / LIFF โดยตรง หรือค้นหาด้วยเลข VN — ช่องทางที่ใช้งานได้แล้ววันนี้</a:t>
+            </a:r>
+            <a:endParaRPr lang="en-US" sz="1300" dirty="0"/>
+          </a:p>
+        </p:txBody>
+      </p:sp>
+      <p:sp>
+        <p:nvSpPr>
+          <p:cNvPr id="11" name="Shape 8"/>
+          <p:cNvSpPr/>
+          <p:nvPr/>
+        </p:nvSpPr>
+        <p:spPr>
+          <a:xfrm>
+            <a:off x="6370168" y="1965960"/>
+            <a:ext cx="5272888" cy="3063240"/>
+          </a:xfrm>
+          <a:prstGeom prst="roundRect">
+            <a:avLst>
+              <a:gd name="adj" fmla="val 3582"/>
+            </a:avLst>
+          </a:prstGeom>
+          <a:solidFill>
+            <a:srgbClr val="EAF6F4"/>
+          </a:solidFill>
+          <a:ln/>
+          <a:effectLst>
+            <a:outerShdw sx="100000" sy="100000" kx="0" ky="0" algn="bl" rotWithShape="0" blurRad="101600" dist="25400" dir="5400000">
+              <a:srgbClr val="1B3A38">
+                <a:alpha val="15000"/>
+              </a:srgbClr>
+            </a:outerShdw>
+          </a:effectLst>
+        </p:spPr>
+      </p:sp>
+      <p:sp>
+        <p:nvSpPr>
+          <p:cNvPr id="12" name="Shape 9"/>
+          <p:cNvSpPr/>
+          <p:nvPr/>
+        </p:nvSpPr>
+        <p:spPr>
+          <a:xfrm>
+            <a:off x="9677095" y="2194560"/>
+            <a:ext cx="1737360" cy="365760"/>
           </a:xfrm>
           <a:prstGeom prst="roundRect">
             <a:avLst>
@@ -2406,14 +2692,14 @@
       </p:sp>
       <p:sp>
         <p:nvSpPr>
-          <p:cNvPr id="5" name="Text 3"/>
-          <p:cNvSpPr txBox="1"/>
-          <p:nvPr/>
-        </p:nvSpPr>
-        <p:spPr>
-          <a:xfrm>
-            <a:off x="9722815" y="457200"/>
-            <a:ext cx="1920240" cy="384048"/>
+          <p:cNvPr id="13" name="Text 10"/>
+          <p:cNvSpPr txBox="1"/>
+          <p:nvPr/>
+        </p:nvSpPr>
+        <p:spPr>
+          <a:xfrm>
+            <a:off x="9677095" y="2194560"/>
+            <a:ext cx="1737360" cy="365760"/>
           </a:xfrm>
           <a:prstGeom prst="rect">
             <a:avLst/>
@@ -2429,7 +2715,7 @@
               <a:buNone/>
             </a:pPr>
             <a:r>
-              <a:rPr lang="en-US" sz="1050" b="1" dirty="0">
+              <a:rPr lang="en-US" sz="950" b="1" dirty="0">
                 <a:solidFill>
                   <a:srgbClr val="A15C00"/>
                 </a:solidFill>
@@ -2437,203 +2723,11 @@
                 <a:ea typeface="Calibri" pitchFamily="34" charset="-122"/>
                 <a:cs typeface="Calibri" pitchFamily="34" charset="-120"/>
               </a:rPr>
-              <a:t>แนวคิด — ยังไม่ได้พัฒนา</a:t>
-            </a:r>
-            <a:endParaRPr lang="en-US" sz="1050" dirty="0"/>
-          </a:p>
-        </p:txBody>
-      </p:sp>
-      <p:sp>
-        <p:nvSpPr>
-          <p:cNvPr id="6" name="Shape 4"/>
-          <p:cNvSpPr/>
-          <p:nvPr/>
-        </p:nvSpPr>
-        <p:spPr>
-          <a:xfrm>
-            <a:off x="548640" y="2103120"/>
-            <a:ext cx="3291840" cy="3017520"/>
-          </a:xfrm>
-          <a:prstGeom prst="roundRect">
-            <a:avLst>
-              <a:gd name="adj" fmla="val 3636"/>
-            </a:avLst>
-          </a:prstGeom>
-          <a:solidFill>
-            <a:srgbClr val="EAF6F4"/>
-          </a:solidFill>
-          <a:ln/>
-          <a:effectLst>
-            <a:outerShdw sx="100000" sy="100000" kx="0" ky="0" algn="bl" rotWithShape="0" blurRad="101600" dist="25400" dir="5400000">
-              <a:srgbClr val="1B3A38">
-                <a:alpha val="15000"/>
-              </a:srgbClr>
-            </a:outerShdw>
-          </a:effectLst>
-        </p:spPr>
-      </p:sp>
-      <p:sp>
-        <p:nvSpPr>
-          <p:cNvPr id="7" name="Shape 5"/>
-          <p:cNvSpPr/>
-          <p:nvPr/>
-        </p:nvSpPr>
-        <p:spPr>
-          <a:xfrm>
-            <a:off x="868680" y="2423160"/>
-            <a:ext cx="548640" cy="548640"/>
-          </a:xfrm>
-          <a:prstGeom prst="ellipse">
-            <a:avLst/>
-          </a:prstGeom>
-          <a:solidFill>
-            <a:srgbClr val="028090"/>
-          </a:solidFill>
-          <a:ln/>
-        </p:spPr>
-      </p:sp>
-      <p:pic>
-        <p:nvPicPr>
-          <p:cNvPr id="8" name="Image 0" descr="preencoded.png">    </p:cNvPr>
-          <p:cNvPicPr>
-            <a:picLocks noChangeAspect="1"/>
-          </p:cNvPicPr>
-          <p:nvPr/>
-        </p:nvPicPr>
-        <p:blipFill>
-          <a:blip r:embed="rId1"/>
-          <a:stretch>
-            <a:fillRect/>
-          </a:stretch>
-        </p:blipFill>
-        <p:spPr>
-          <a:xfrm>
-            <a:off x="996696" y="2551176"/>
-            <a:ext cx="292608" cy="292608"/>
-          </a:xfrm>
-          <a:prstGeom prst="rect">
-            <a:avLst/>
-          </a:prstGeom>
-        </p:spPr>
-      </p:pic>
-      <p:sp>
-        <p:nvSpPr>
-          <p:cNvPr id="9" name="Text 6"/>
-          <p:cNvSpPr txBox="1"/>
-          <p:nvPr/>
-        </p:nvSpPr>
-        <p:spPr>
-          <a:xfrm>
-            <a:off x="822960" y="3108960"/>
-            <a:ext cx="2743200" cy="365760"/>
-          </a:xfrm>
-          <a:prstGeom prst="rect">
-            <a:avLst/>
-          </a:prstGeom>
-          <a:noFill/>
-          <a:ln/>
-        </p:spPr>
-        <p:txBody>
-          <a:bodyPr wrap="square" lIns="0" tIns="0" rIns="0" bIns="0" rtlCol="0" anchor="ctr"/>
-          <a:lstStyle/>
-          <a:p>
-            <a:pPr indent="0" marL="0">
-              <a:buNone/>
-            </a:pPr>
-            <a:r>
-              <a:rPr lang="en-US" sz="1400" b="1" dirty="0">
-                <a:solidFill>
-                  <a:srgbClr val="17262A"/>
-                </a:solidFill>
-                <a:latin typeface="Cambria" pitchFamily="34" charset="0"/>
-                <a:ea typeface="Cambria" pitchFamily="34" charset="-122"/>
-                <a:cs typeface="Cambria" pitchFamily="34" charset="-120"/>
-              </a:rPr>
-              <a:t>ใบนำทาง (เดิม)</a:t>
-            </a:r>
-            <a:endParaRPr lang="en-US" sz="1400" dirty="0"/>
-          </a:p>
-        </p:txBody>
-      </p:sp>
-      <p:sp>
-        <p:nvSpPr>
-          <p:cNvPr id="10" name="Shape 7"/>
-          <p:cNvSpPr/>
-          <p:nvPr/>
-        </p:nvSpPr>
-        <p:spPr>
-          <a:xfrm>
-            <a:off x="822960" y="3611880"/>
-            <a:ext cx="2468880" cy="91440"/>
-          </a:xfrm>
-          <a:prstGeom prst="rect">
-            <a:avLst/>
-          </a:prstGeom>
-          <a:solidFill>
-            <a:srgbClr val="D6E9E6"/>
-          </a:solidFill>
-          <a:ln/>
-        </p:spPr>
-      </p:sp>
-      <p:sp>
-        <p:nvSpPr>
-          <p:cNvPr id="11" name="Shape 8"/>
-          <p:cNvSpPr/>
-          <p:nvPr/>
-        </p:nvSpPr>
-        <p:spPr>
-          <a:xfrm>
-            <a:off x="822960" y="3904488"/>
-            <a:ext cx="2468880" cy="91440"/>
-          </a:xfrm>
-          <a:prstGeom prst="rect">
-            <a:avLst/>
-          </a:prstGeom>
-          <a:solidFill>
-            <a:srgbClr val="D6E9E6"/>
-          </a:solidFill>
-          <a:ln/>
-        </p:spPr>
-      </p:sp>
-      <p:sp>
-        <p:nvSpPr>
-          <p:cNvPr id="12" name="Shape 9"/>
-          <p:cNvSpPr/>
-          <p:nvPr/>
-        </p:nvSpPr>
-        <p:spPr>
-          <a:xfrm>
-            <a:off x="822960" y="4197096"/>
-            <a:ext cx="2468880" cy="91440"/>
-          </a:xfrm>
-          <a:prstGeom prst="rect">
-            <a:avLst/>
-          </a:prstGeom>
-          <a:solidFill>
-            <a:srgbClr val="D6E9E6"/>
-          </a:solidFill>
-          <a:ln/>
-        </p:spPr>
-      </p:sp>
-      <p:sp>
-        <p:nvSpPr>
-          <p:cNvPr id="13" name="Shape 10"/>
-          <p:cNvSpPr/>
-          <p:nvPr/>
-        </p:nvSpPr>
-        <p:spPr>
-          <a:xfrm>
-            <a:off x="822960" y="4489704"/>
-            <a:ext cx="2468880" cy="91440"/>
-          </a:xfrm>
-          <a:prstGeom prst="rect">
-            <a:avLst/>
-          </a:prstGeom>
-          <a:solidFill>
-            <a:srgbClr val="D6E9E6"/>
-          </a:solidFill>
-          <a:ln/>
-        </p:spPr>
+              <a:t>แนวคิด — ยังไม่พัฒนา</a:t>
+            </a:r>
+            <a:endParaRPr lang="en-US" sz="950" dirty="0"/>
+          </a:p>
+        </p:txBody>
       </p:sp>
       <p:sp>
         <p:nvSpPr>
@@ -2643,14 +2737,14 @@
         </p:nvSpPr>
         <p:spPr>
           <a:xfrm>
-            <a:off x="3977640" y="3291840"/>
-            <a:ext cx="640080" cy="640080"/>
+            <a:off x="6690208" y="2286000"/>
+            <a:ext cx="777240" cy="777240"/>
           </a:xfrm>
           <a:prstGeom prst="ellipse">
             <a:avLst/>
           </a:prstGeom>
           <a:solidFill>
-            <a:srgbClr val="02C39A"/>
+            <a:srgbClr val="00A896"/>
           </a:solidFill>
           <a:ln/>
         </p:spPr>
@@ -2671,8 +2765,8 @@
         </p:blipFill>
         <p:spPr>
           <a:xfrm>
-            <a:off x="4142232" y="3456432"/>
-            <a:ext cx="310896" cy="310896"/>
+            <a:off x="6891376" y="2487168"/>
+            <a:ext cx="374904" cy="374904"/>
           </a:xfrm>
           <a:prstGeom prst="rect">
             <a:avLst/>
@@ -2681,171 +2775,169 @@
       </p:pic>
       <p:sp>
         <p:nvSpPr>
-          <p:cNvPr id="16" name="Shape 12"/>
-          <p:cNvSpPr/>
-          <p:nvPr/>
-        </p:nvSpPr>
-        <p:spPr>
-          <a:xfrm>
-            <a:off x="4892040" y="2103120"/>
-            <a:ext cx="3291840" cy="3017520"/>
-          </a:xfrm>
-          <a:prstGeom prst="roundRect">
-            <a:avLst>
-              <a:gd name="adj" fmla="val 3636"/>
-            </a:avLst>
-          </a:prstGeom>
-          <a:solidFill>
-            <a:srgbClr val="028090"/>
-          </a:solidFill>
-          <a:ln/>
-          <a:effectLst>
-            <a:outerShdw sx="100000" sy="100000" kx="0" ky="0" algn="bl" rotWithShape="0" blurRad="101600" dist="25400" dir="5400000">
-              <a:srgbClr val="1B3A38">
-                <a:alpha val="15000"/>
-              </a:srgbClr>
-            </a:outerShdw>
-          </a:effectLst>
-        </p:spPr>
-      </p:sp>
-      <p:sp>
-        <p:nvSpPr>
-          <p:cNvPr id="17" name="Shape 13"/>
-          <p:cNvSpPr/>
-          <p:nvPr/>
-        </p:nvSpPr>
-        <p:spPr>
-          <a:xfrm>
-            <a:off x="6080760" y="2468880"/>
-            <a:ext cx="914400" cy="914400"/>
-          </a:xfrm>
-          <a:prstGeom prst="ellipse">
-            <a:avLst/>
-          </a:prstGeom>
-          <a:solidFill>
-            <a:srgbClr val="FFFFFF"/>
-          </a:solidFill>
-          <a:ln/>
-        </p:spPr>
-      </p:sp>
-      <p:pic>
-        <p:nvPicPr>
-          <p:cNvPr id="18" name="Image 2" descr="preencoded.png">    </p:cNvPr>
-          <p:cNvPicPr>
-            <a:picLocks noChangeAspect="1"/>
-          </p:cNvPicPr>
-          <p:nvPr/>
-        </p:nvPicPr>
-        <p:blipFill>
-          <a:blip r:embed="rId3"/>
-          <a:stretch>
-            <a:fillRect/>
-          </a:stretch>
-        </p:blipFill>
-        <p:spPr>
-          <a:xfrm>
-            <a:off x="6227064" y="2615184"/>
-            <a:ext cx="621792" cy="621792"/>
-          </a:xfrm>
-          <a:prstGeom prst="rect">
-            <a:avLst/>
-          </a:prstGeom>
-        </p:spPr>
-      </p:pic>
-      <p:sp>
-        <p:nvSpPr>
-          <p:cNvPr id="19" name="Text 14"/>
-          <p:cNvSpPr txBox="1"/>
-          <p:nvPr/>
-        </p:nvSpPr>
-        <p:spPr>
-          <a:xfrm>
-            <a:off x="4892040" y="3566160"/>
-            <a:ext cx="3291840" cy="365760"/>
-          </a:xfrm>
-          <a:prstGeom prst="rect">
-            <a:avLst/>
-          </a:prstGeom>
-          <a:noFill/>
-          <a:ln/>
-        </p:spPr>
-        <p:txBody>
-          <a:bodyPr wrap="square" lIns="0" tIns="0" rIns="0" bIns="0" rtlCol="0" anchor="ctr"/>
-          <a:lstStyle/>
-          <a:p>
-            <a:pPr algn="ctr" indent="0" marL="0">
-              <a:buNone/>
-            </a:pPr>
-            <a:r>
-              <a:rPr lang="en-US" sz="1600" b="1" dirty="0">
-                <a:solidFill>
-                  <a:srgbClr val="FFFFFF"/>
+          <p:cNvPr id="16" name="Text 12"/>
+          <p:cNvSpPr txBox="1"/>
+          <p:nvPr/>
+        </p:nvSpPr>
+        <p:spPr>
+          <a:xfrm>
+            <a:off x="6690208" y="3246120"/>
+            <a:ext cx="4632808" cy="411480"/>
+          </a:xfrm>
+          <a:prstGeom prst="rect">
+            <a:avLst/>
+          </a:prstGeom>
+          <a:noFill/>
+          <a:ln/>
+        </p:spPr>
+        <p:txBody>
+          <a:bodyPr wrap="square" lIns="0" tIns="0" rIns="0" bIns="0" rtlCol="0" anchor="ctr"/>
+          <a:lstStyle/>
+          <a:p>
+            <a:pPr indent="0" marL="0">
+              <a:buNone/>
+            </a:pPr>
+            <a:r>
+              <a:rPr lang="en-US" sz="1700" b="1" dirty="0">
+                <a:solidFill>
+                  <a:srgbClr val="17262A"/>
                 </a:solidFill>
                 <a:latin typeface="Cambria" pitchFamily="34" charset="0"/>
                 <a:ea typeface="Cambria" pitchFamily="34" charset="-122"/>
                 <a:cs typeface="Cambria" pitchFamily="34" charset="-120"/>
               </a:rPr>
-              <a:t>+ QR Code</a:t>
-            </a:r>
-            <a:endParaRPr lang="en-US" sz="1600" dirty="0"/>
-          </a:p>
-        </p:txBody>
-      </p:sp>
-      <p:sp>
-        <p:nvSpPr>
-          <p:cNvPr id="20" name="Text 15"/>
-          <p:cNvSpPr txBox="1"/>
-          <p:nvPr/>
-        </p:nvSpPr>
-        <p:spPr>
-          <a:xfrm>
-            <a:off x="5166360" y="4023360"/>
-            <a:ext cx="2743200" cy="914400"/>
-          </a:xfrm>
-          <a:prstGeom prst="rect">
-            <a:avLst/>
-          </a:prstGeom>
-          <a:noFill/>
-          <a:ln/>
-        </p:spPr>
-        <p:txBody>
-          <a:bodyPr wrap="square" lIns="0" tIns="0" rIns="0" bIns="0" rtlCol="0" anchor="ctr"/>
-          <a:lstStyle/>
-          <a:p>
-            <a:pPr algn="ctr" indent="0" marL="0">
+              <a:t>แนวทางที่ 2 — สแกน QR บนใบนำทาง</a:t>
+            </a:r>
+            <a:endParaRPr lang="en-US" sz="1700" dirty="0"/>
+          </a:p>
+        </p:txBody>
+      </p:sp>
+      <p:sp>
+        <p:nvSpPr>
+          <p:cNvPr id="17" name="Text 13"/>
+          <p:cNvSpPr txBox="1"/>
+          <p:nvPr/>
+        </p:nvSpPr>
+        <p:spPr>
+          <a:xfrm>
+            <a:off x="6690208" y="3749040"/>
+            <a:ext cx="4632808" cy="1005840"/>
+          </a:xfrm>
+          <a:prstGeom prst="rect">
+            <a:avLst/>
+          </a:prstGeom>
+          <a:noFill/>
+          <a:ln/>
+        </p:spPr>
+        <p:txBody>
+          <a:bodyPr wrap="square" lIns="0" tIns="0" rIns="0" bIns="0" rtlCol="0" anchor="ctr"/>
+          <a:lstStyle/>
+          <a:p>
+            <a:pPr indent="0" marL="0">
               <a:lnSpc>
-                <a:spcPct val="115000"/>
+                <a:spcPct val="120000"/>
               </a:lnSpc>
               <a:buNone/>
             </a:pPr>
             <a:r>
-              <a:rPr lang="en-US" sz="1250" dirty="0">
-                <a:solidFill>
-                  <a:srgbClr val="BFE3DE"/>
+              <a:rPr lang="en-US" sz="1300" dirty="0">
+                <a:solidFill>
+                  <a:srgbClr val="5A6E6C"/>
                 </a:solidFill>
                 <a:latin typeface="Calibri" pitchFamily="34" charset="0"/>
                 <a:ea typeface="Calibri" pitchFamily="34" charset="-122"/>
                 <a:cs typeface="Calibri" pitchFamily="34" charset="-120"/>
               </a:rPr>
-              <a:t>สแกนแล้วเข้าสู่ journey ของผู้ป่วยรายนั้นทันที แทนการค้นหาเลข VN เอง</a:t>
-            </a:r>
-            <a:endParaRPr lang="en-US" sz="1250" dirty="0"/>
-          </a:p>
-        </p:txBody>
-      </p:sp>
-      <p:sp>
-        <p:nvSpPr>
-          <p:cNvPr id="21" name="Shape 16"/>
+              <a:t>เพิ่ม QR code ลงบนใบนำทางเดิมที่ทุกโรงพยาบาลมีอยู่แล้ว — สแกนแล้วเข้าสู่ journey ของผู้ป่วยรายนั้นทันที แทนการค้นหาเลข VN เอง</a:t>
+            </a:r>
+            <a:endParaRPr lang="en-US" sz="1300" dirty="0"/>
+          </a:p>
+        </p:txBody>
+      </p:sp>
+      <p:sp>
+        <p:nvSpPr>
+          <p:cNvPr id="18" name="Shape 14"/>
           <p:cNvSpPr/>
           <p:nvPr/>
         </p:nvSpPr>
         <p:spPr>
           <a:xfrm>
-            <a:off x="8321040" y="3291840"/>
-            <a:ext cx="640080" cy="640080"/>
-          </a:xfrm>
-          <a:prstGeom prst="ellipse">
-            <a:avLst/>
+            <a:off x="3185084" y="5029200"/>
+            <a:ext cx="0" cy="274320"/>
+          </a:xfrm>
+          <a:prstGeom prst="line">
+            <a:avLst/>
+          </a:prstGeom>
+          <a:noFill/>
+          <a:ln w="25400">
+            <a:solidFill>
+              <a:srgbClr val="00A896"/>
+            </a:solidFill>
+            <a:prstDash val="dash"/>
+          </a:ln>
+        </p:spPr>
+      </p:sp>
+      <p:sp>
+        <p:nvSpPr>
+          <p:cNvPr id="19" name="Shape 15"/>
+          <p:cNvSpPr/>
+          <p:nvPr/>
+        </p:nvSpPr>
+        <p:spPr>
+          <a:xfrm>
+            <a:off x="9006611" y="5029200"/>
+            <a:ext cx="0" cy="274320"/>
+          </a:xfrm>
+          <a:prstGeom prst="line">
+            <a:avLst/>
+          </a:prstGeom>
+          <a:noFill/>
+          <a:ln w="25400">
+            <a:solidFill>
+              <a:srgbClr val="00A896"/>
+            </a:solidFill>
+            <a:prstDash val="dash"/>
+          </a:ln>
+        </p:spPr>
+      </p:sp>
+      <p:sp>
+        <p:nvSpPr>
+          <p:cNvPr id="20" name="Shape 16"/>
+          <p:cNvSpPr/>
+          <p:nvPr/>
+        </p:nvSpPr>
+        <p:spPr>
+          <a:xfrm>
+            <a:off x="3185084" y="5303520"/>
+            <a:ext cx="5821528" cy="0"/>
+          </a:xfrm>
+          <a:prstGeom prst="line">
+            <a:avLst/>
+          </a:prstGeom>
+          <a:noFill/>
+          <a:ln w="25400">
+            <a:solidFill>
+              <a:srgbClr val="00A896"/>
+            </a:solidFill>
+            <a:prstDash val="dash"/>
+          </a:ln>
+        </p:spPr>
+      </p:sp>
+      <p:sp>
+        <p:nvSpPr>
+          <p:cNvPr id="21" name="Shape 17"/>
+          <p:cNvSpPr/>
+          <p:nvPr/>
+        </p:nvSpPr>
+        <p:spPr>
+          <a:xfrm>
+            <a:off x="4449928" y="5074920"/>
+            <a:ext cx="3291840" cy="457200"/>
+          </a:xfrm>
+          <a:prstGeom prst="roundRect">
+            <a:avLst>
+              <a:gd name="adj" fmla="val 50000"/>
+            </a:avLst>
           </a:prstGeom>
           <a:solidFill>
             <a:srgbClr val="02C39A"/>
@@ -2853,113 +2945,16 @@
           <a:ln/>
         </p:spPr>
       </p:sp>
-      <p:pic>
-        <p:nvPicPr>
-          <p:cNvPr id="22" name="Image 3" descr="preencoded.png">    </p:cNvPr>
-          <p:cNvPicPr>
-            <a:picLocks noChangeAspect="1"/>
-          </p:cNvPicPr>
-          <p:nvPr/>
-        </p:nvPicPr>
-        <p:blipFill>
-          <a:blip r:embed="rId4"/>
-          <a:stretch>
-            <a:fillRect/>
-          </a:stretch>
-        </p:blipFill>
-        <p:spPr>
-          <a:xfrm>
-            <a:off x="8485632" y="3456432"/>
-            <a:ext cx="310896" cy="310896"/>
-          </a:xfrm>
-          <a:prstGeom prst="rect">
-            <a:avLst/>
-          </a:prstGeom>
-        </p:spPr>
-      </p:pic>
-      <p:sp>
-        <p:nvSpPr>
-          <p:cNvPr id="23" name="Shape 17"/>
-          <p:cNvSpPr/>
-          <p:nvPr/>
-        </p:nvSpPr>
-        <p:spPr>
-          <a:xfrm>
-            <a:off x="9235440" y="2103120"/>
-            <a:ext cx="2407615" cy="3017520"/>
-          </a:xfrm>
-          <a:prstGeom prst="roundRect">
-            <a:avLst>
-              <a:gd name="adj" fmla="val 4558"/>
-            </a:avLst>
-          </a:prstGeom>
-          <a:solidFill>
-            <a:srgbClr val="EAF6F4"/>
-          </a:solidFill>
-          <a:ln/>
-          <a:effectLst>
-            <a:outerShdw sx="100000" sy="100000" kx="0" ky="0" algn="bl" rotWithShape="0" blurRad="101600" dist="25400" dir="5400000">
-              <a:srgbClr val="1B3A38">
-                <a:alpha val="15000"/>
-              </a:srgbClr>
-            </a:outerShdw>
-          </a:effectLst>
-        </p:spPr>
-      </p:sp>
-      <p:sp>
-        <p:nvSpPr>
-          <p:cNvPr id="24" name="Shape 18"/>
-          <p:cNvSpPr/>
-          <p:nvPr/>
-        </p:nvSpPr>
-        <p:spPr>
-          <a:xfrm>
-            <a:off x="10119208" y="2423160"/>
-            <a:ext cx="640080" cy="640080"/>
-          </a:xfrm>
-          <a:prstGeom prst="ellipse">
-            <a:avLst/>
-          </a:prstGeom>
-          <a:solidFill>
-            <a:srgbClr val="00A896"/>
-          </a:solidFill>
-          <a:ln/>
-        </p:spPr>
-      </p:sp>
-      <p:pic>
-        <p:nvPicPr>
-          <p:cNvPr id="25" name="Image 4" descr="preencoded.png">    </p:cNvPr>
-          <p:cNvPicPr>
-            <a:picLocks noChangeAspect="1"/>
-          </p:cNvPicPr>
-          <p:nvPr/>
-        </p:nvPicPr>
-        <p:blipFill>
-          <a:blip r:embed="rId5"/>
-          <a:stretch>
-            <a:fillRect/>
-          </a:stretch>
-        </p:blipFill>
-        <p:spPr>
-          <a:xfrm>
-            <a:off x="10274656" y="2578608"/>
-            <a:ext cx="329184" cy="329184"/>
-          </a:xfrm>
-          <a:prstGeom prst="rect">
-            <a:avLst/>
-          </a:prstGeom>
-        </p:spPr>
-      </p:pic>
-      <p:sp>
-        <p:nvSpPr>
-          <p:cNvPr id="26" name="Text 19"/>
-          <p:cNvSpPr txBox="1"/>
-          <p:nvPr/>
-        </p:nvSpPr>
-        <p:spPr>
-          <a:xfrm>
-            <a:off x="9464040" y="3246120"/>
-            <a:ext cx="1950415" cy="731520"/>
+      <p:sp>
+        <p:nvSpPr>
+          <p:cNvPr id="22" name="Text 18"/>
+          <p:cNvSpPr txBox="1"/>
+          <p:nvPr/>
+        </p:nvSpPr>
+        <p:spPr>
+          <a:xfrm>
+            <a:off x="4449928" y="5074920"/>
+            <a:ext cx="3291840" cy="457200"/>
           </a:xfrm>
           <a:prstGeom prst="rect">
             <a:avLst/>
@@ -2972,21 +2967,18 @@
           <a:lstStyle/>
           <a:p>
             <a:pPr algn="ctr" indent="0" marL="0">
-              <a:lnSpc>
-                <a:spcPct val="115000"/>
-              </a:lnSpc>
-              <a:buNone/>
-            </a:pPr>
-            <a:r>
-              <a:rPr lang="en-US" sz="1250" dirty="0">
-                <a:solidFill>
-                  <a:srgbClr val="17262A"/>
+              <a:buNone/>
+            </a:pPr>
+            <a:r>
+              <a:rPr lang="en-US" sz="1250" b="1" dirty="0">
+                <a:solidFill>
+                  <a:srgbClr val="FFFFFF"/>
                 </a:solidFill>
                 <a:latin typeface="Calibri" pitchFamily="34" charset="0"/>
                 <a:ea typeface="Calibri" pitchFamily="34" charset="-122"/>
                 <a:cs typeface="Calibri" pitchFamily="34" charset="-120"/>
               </a:rPr>
-              <a:t>เข้าหน้า Journey ของผู้ป่วยทันที</a:t>
+              <a:t>เข้าสู่หน้า Journey เดียวกัน</a:t>
             </a:r>
             <a:endParaRPr lang="en-US" sz="1250" dirty="0"/>
           </a:p>
@@ -2994,13 +2986,13 @@
       </p:sp>
       <p:sp>
         <p:nvSpPr>
-          <p:cNvPr id="27" name="Text 20"/>
-          <p:cNvSpPr txBox="1"/>
-          <p:nvPr/>
-        </p:nvSpPr>
-        <p:spPr>
-          <a:xfrm>
-            <a:off x="548640" y="6309360"/>
+          <p:cNvPr id="23" name="Text 19"/>
+          <p:cNvSpPr txBox="1"/>
+          <p:nvPr/>
+        </p:nvSpPr>
+        <p:spPr>
+          <a:xfrm>
+            <a:off x="548640" y="6172200"/>
             <a:ext cx="11094415" cy="457200"/>
           </a:xfrm>
           <a:prstGeom prst="rect">
@@ -3025,7 +3017,7 @@
                 <a:ea typeface="Calibri" pitchFamily="34" charset="-122"/>
                 <a:cs typeface="Calibri" pitchFamily="34" charset="-120"/>
               </a:rPr>
-              <a:t>ต่อยอดจาก pattern QR location provider ที่มีอยู่แล้ว (ADR-0004) — เป็น QR จุดเข้าใหม่ ไม่ใช่ระบบใหม่</a:t>
+              <a:t>แนวทางที่ 2 ต่อยอดจาก pattern QR location provider ที่มีอยู่แล้ว (ADR-0004) — เป็น QR จุดเข้าใหม่ ไม่ใช่ระบบใหม่ เพราะทุกโรงพยาบาลมีใบนำทางอยู่แล้ว</a:t>
             </a:r>
             <a:endParaRPr lang="en-US" sz="1100" dirty="0"/>
           </a:p>
@@ -3033,7 +3025,7 @@
       </p:sp>
       <p:sp>
         <p:nvSpPr>
-          <p:cNvPr id="29" name="Text 21"/>
+          <p:cNvPr id="25" name="Text 20"/>
           <p:cNvSpPr txBox="1"/>
           <p:nvPr/>
         </p:nvSpPr>

</xml_diff>

<commit_message>
Correct slide 10: the referral-slip QR is already built, not a proposal
The user pointed out the QR is generated per visit in Mock HIS today
(GET /api/v1/demo/visits/{visitId}/qrcode.png, shown in console.html) and
deep-links straight to the patient journey. The only remaining work for a
real hospital is printing that QR onto the hospital's actual physical
ใบนำทาง — a rollout step, not development. Updates the deck, outline, and
Thai script to stop calling this an unbuilt idea.

Co-Authored-By: Claude Sonnet 5 <noreply@anthropic.com>
</commit_message>
<xml_diff>
--- a/docs/deliverables/presentation-outline-hospital-review.pptx
+++ b/docs/deliverables/presentation-outline-hospital-review.pptx
@@ -605,7 +605,8 @@
             <a:r>
               <a:rPr lang="en-US" dirty="0"/>
               <a:t>~20s
-มีสองแนวทางที่ผู้มารับบริการจะเปิดใช้งาน CarePath ได้ แนวทางแรกคือผ่าน LINE LIFF ซึ่งใช้งานได้แล้ววันนี้ แนวทางที่สองที่อยากนำเสนอเพิ่มเติม แต่ขอย้ำว่ายังไม่ได้พัฒนาจริง คือการเพิ่ม QR code ลงบนใบนำทางที่โรงพยาบาลใช้อยู่แล้ว เมื่อผู้ป่วยสแกน ก็จะเข้าสู่หน้า journey ของตัวเองใน CarePath ได้ทันที เหตุผลที่เลือกใบนำทางเป็นจุดเริ่มต้น เพราะทุกโรงพยาบาลมีเอกสารนี้อยู่แล้ว ไม่ต้องออกแบบเอกสารใหม่ ทั้งสองแนวทางพาไปสู่หน้า journey เดียวกัน</a:t>
+มีสองแนวทางที่ผู้มารับบริการจะเปิดใช้งาน CarePath ได้ แนวทางแรกคือผ่าน LINE LIFF ซึ่งใช้งานได้แล้ววันนี้
+แนวทางที่สองคือสแกน QR บนใบนำทาง ซึ่งตัว QR นี้ทำเสร็จแล้วจริง ๆ อยู่ในหน้าคอนโซลของ Mock HIS ทุก visit มี QR ของตัวเอง สแกนแล้วเข้าสู่ journey ของผู้ป่วยรายนั้นทันที สิ่งที่เหลืออยู่ไม่ใช่การพัฒนาโค้ดเพิ่ม แต่เป็นขั้นตอนตอนติดตั้งจริงกับโรงพยาบาล คือต้องนำ QR ตัวเดียวกันนี้ไปพิมพ์ลงบนใบนำทางจริงที่มอบให้ผู้ป่วย ซึ่งทุกโรงพยาบาลมีเอกสารนี้อยู่แล้ว ไม่ต้องออกแบบเอกสารใหม่ ทั้งสองแนวทางพาไปสู่หน้า journey เดียวกัน</a:t>
             </a:r>
             <a:endParaRPr lang="en-US" dirty="0"/>
           </a:p>
@@ -2451,8 +2452,8 @@
         </p:nvSpPr>
         <p:spPr>
           <a:xfrm>
-            <a:off x="3855568" y="2194560"/>
-            <a:ext cx="1737360" cy="365760"/>
+            <a:off x="3581248" y="2194560"/>
+            <a:ext cx="2011680" cy="365760"/>
           </a:xfrm>
           <a:prstGeom prst="roundRect">
             <a:avLst>
@@ -2478,8 +2479,8 @@
         </p:nvSpPr>
         <p:spPr>
           <a:xfrm>
-            <a:off x="3855568" y="2194560"/>
-            <a:ext cx="1737360" cy="365760"/>
+            <a:off x="3581248" y="2194560"/>
+            <a:ext cx="2011680" cy="365760"/>
           </a:xfrm>
           <a:prstGeom prst="rect">
             <a:avLst/>
@@ -2671,8 +2672,8 @@
         </p:nvSpPr>
         <p:spPr>
           <a:xfrm>
-            <a:off x="9677095" y="2194560"/>
-            <a:ext cx="1737360" cy="365760"/>
+            <a:off x="9402775" y="2194560"/>
+            <a:ext cx="2011680" cy="365760"/>
           </a:xfrm>
           <a:prstGeom prst="roundRect">
             <a:avLst>
@@ -2680,11 +2681,11 @@
             </a:avLst>
           </a:prstGeom>
           <a:solidFill>
-            <a:srgbClr val="FFF3E0"/>
+            <a:srgbClr val="E3F6EE"/>
           </a:solidFill>
           <a:ln w="12700">
             <a:solidFill>
-              <a:srgbClr val="A15C00"/>
+              <a:srgbClr val="0E8A5F"/>
             </a:solidFill>
             <a:prstDash val="solid"/>
           </a:ln>
@@ -2698,8 +2699,8 @@
         </p:nvSpPr>
         <p:spPr>
           <a:xfrm>
-            <a:off x="9677095" y="2194560"/>
-            <a:ext cx="1737360" cy="365760"/>
+            <a:off x="9402775" y="2194560"/>
+            <a:ext cx="2011680" cy="365760"/>
           </a:xfrm>
           <a:prstGeom prst="rect">
             <a:avLst/>
@@ -2715,17 +2716,17 @@
               <a:buNone/>
             </a:pPr>
             <a:r>
-              <a:rPr lang="en-US" sz="950" b="1" dirty="0">
-                <a:solidFill>
-                  <a:srgbClr val="A15C00"/>
+              <a:rPr lang="en-US" sz="1050" b="1" dirty="0">
+                <a:solidFill>
+                  <a:srgbClr val="0E8A5F"/>
                 </a:solidFill>
                 <a:latin typeface="Calibri" pitchFamily="34" charset="0"/>
                 <a:ea typeface="Calibri" pitchFamily="34" charset="-122"/>
                 <a:cs typeface="Calibri" pitchFamily="34" charset="-120"/>
               </a:rPr>
-              <a:t>แนวคิด — ยังไม่พัฒนา</a:t>
-            </a:r>
-            <a:endParaRPr lang="en-US" sz="950" dirty="0"/>
+              <a:t>ทำแล้ว (Mock HIS)</a:t>
+            </a:r>
+            <a:endParaRPr lang="en-US" sz="1050" dirty="0"/>
           </a:p>
         </p:txBody>
       </p:sp>
@@ -2744,7 +2745,7 @@
             <a:avLst/>
           </a:prstGeom>
           <a:solidFill>
-            <a:srgbClr val="00A896"/>
+            <a:srgbClr val="028090"/>
           </a:solidFill>
           <a:ln/>
         </p:spPr>
@@ -2821,7 +2822,7 @@
         <p:spPr>
           <a:xfrm>
             <a:off x="6690208" y="3749040"/>
-            <a:ext cx="4632808" cy="1005840"/>
+            <a:ext cx="4632808" cy="548640"/>
           </a:xfrm>
           <a:prstGeom prst="rect">
             <a:avLst/>
@@ -2848,7 +2849,7 @@
                 <a:ea typeface="Calibri" pitchFamily="34" charset="-122"/>
                 <a:cs typeface="Calibri" pitchFamily="34" charset="-120"/>
               </a:rPr>
-              <a:t>เพิ่ม QR code ลงบนใบนำทางเดิมที่ทุกโรงพยาบาลมีอยู่แล้ว — สแกนแล้วเข้าสู่ journey ของผู้ป่วยรายนั้นทันที แทนการค้นหาเลข VN เอง</a:t>
+              <a:t>Mock HIS สร้าง QR ต่อ visit ให้แล้ว สแกนแล้วเข้าสู่ journey ของผู้ป่วยรายนั้นทันที</a:t>
             </a:r>
             <a:endParaRPr lang="en-US" sz="1300" dirty="0"/>
           </a:p>
@@ -2856,7 +2857,49 @@
       </p:sp>
       <p:sp>
         <p:nvSpPr>
-          <p:cNvPr id="18" name="Shape 14"/>
+          <p:cNvPr id="18" name="Text 14"/>
+          <p:cNvSpPr txBox="1"/>
+          <p:nvPr/>
+        </p:nvSpPr>
+        <p:spPr>
+          <a:xfrm>
+            <a:off x="6690208" y="4297680"/>
+            <a:ext cx="4632808" cy="548640"/>
+          </a:xfrm>
+          <a:prstGeom prst="rect">
+            <a:avLst/>
+          </a:prstGeom>
+          <a:noFill/>
+          <a:ln/>
+        </p:spPr>
+        <p:txBody>
+          <a:bodyPr wrap="square" lIns="0" tIns="0" rIns="0" bIns="0" rtlCol="0" anchor="ctr"/>
+          <a:lstStyle/>
+          <a:p>
+            <a:pPr indent="0" marL="0">
+              <a:lnSpc>
+                <a:spcPct val="115000"/>
+              </a:lnSpc>
+              <a:buNone/>
+            </a:pPr>
+            <a:r>
+              <a:rPr lang="en-US" sz="1200" i="1" dirty="0">
+                <a:solidFill>
+                  <a:srgbClr val="A15C00"/>
+                </a:solidFill>
+                <a:latin typeface="Calibri" pitchFamily="34" charset="0"/>
+                <a:ea typeface="Calibri" pitchFamily="34" charset="-122"/>
+                <a:cs typeface="Calibri" pitchFamily="34" charset="-120"/>
+              </a:rPr>
+              <a:t>เหลือ: รพ.จริงต้องนำ QR นี้ไปพิมพ์ลงบนใบนำทางจริงที่มอบให้ผู้ป่วย (ขั้นตอนติดตั้งหน้างาน ไม่ใช่โค้ด)</a:t>
+            </a:r>
+            <a:endParaRPr lang="en-US" sz="1200" dirty="0"/>
+          </a:p>
+        </p:txBody>
+      </p:sp>
+      <p:sp>
+        <p:nvSpPr>
+          <p:cNvPr id="19" name="Shape 15"/>
           <p:cNvSpPr/>
           <p:nvPr/>
         </p:nvSpPr>
@@ -2879,7 +2922,7 @@
       </p:sp>
       <p:sp>
         <p:nvSpPr>
-          <p:cNvPr id="19" name="Shape 15"/>
+          <p:cNvPr id="20" name="Shape 16"/>
           <p:cNvSpPr/>
           <p:nvPr/>
         </p:nvSpPr>
@@ -2902,7 +2945,7 @@
       </p:sp>
       <p:sp>
         <p:nvSpPr>
-          <p:cNvPr id="20" name="Shape 16"/>
+          <p:cNvPr id="21" name="Shape 17"/>
           <p:cNvSpPr/>
           <p:nvPr/>
         </p:nvSpPr>
@@ -2925,7 +2968,7 @@
       </p:sp>
       <p:sp>
         <p:nvSpPr>
-          <p:cNvPr id="21" name="Shape 17"/>
+          <p:cNvPr id="22" name="Shape 18"/>
           <p:cNvSpPr/>
           <p:nvPr/>
         </p:nvSpPr>
@@ -2947,7 +2990,7 @@
       </p:sp>
       <p:sp>
         <p:nvSpPr>
-          <p:cNvPr id="22" name="Text 18"/>
+          <p:cNvPr id="23" name="Text 19"/>
           <p:cNvSpPr txBox="1"/>
           <p:nvPr/>
         </p:nvSpPr>
@@ -2986,7 +3029,7 @@
       </p:sp>
       <p:sp>
         <p:nvSpPr>
-          <p:cNvPr id="23" name="Text 19"/>
+          <p:cNvPr id="24" name="Text 20"/>
           <p:cNvSpPr txBox="1"/>
           <p:nvPr/>
         </p:nvSpPr>
@@ -3017,7 +3060,7 @@
                 <a:ea typeface="Calibri" pitchFamily="34" charset="-122"/>
                 <a:cs typeface="Calibri" pitchFamily="34" charset="-120"/>
               </a:rPr>
-              <a:t>แนวทางที่ 2 ต่อยอดจาก pattern QR location provider ที่มีอยู่แล้ว (ADR-0004) — เป็น QR จุดเข้าใหม่ ไม่ใช่ระบบใหม่ เพราะทุกโรงพยาบาลมีใบนำทางอยู่แล้ว</a:t>
+              <a:t>QR เข้ารหัส URL หน้า journey ของ visit นั้นโดยตรง (Mock HIS: GET /api/v1/demo/visits/{visitId}/qrcode.png) — ของจริงคือ QR เดียวกัน แค่เปลี่ยนที่พิมพ์จากหน้าจอคอนโซล ไปเป็นใบนำทางจริง</a:t>
             </a:r>
             <a:endParaRPr lang="en-US" sz="1100" dirty="0"/>
           </a:p>
@@ -3025,7 +3068,7 @@
       </p:sp>
       <p:sp>
         <p:nvSpPr>
-          <p:cNvPr id="25" name="Text 20"/>
+          <p:cNvPr id="26" name="Text 21"/>
           <p:cNvSpPr txBox="1"/>
           <p:nvPr/>
         </p:nvSpPr>

</xml_diff>